<commit_message>
Remove build-date stamps from documentation and the deck
Provenance is given verbally on stage instead. Measured numbers keep
neutral provenance (probed at build time) so a recorded latency does not
start reading as a live measurement.

Recorded artifacts under artifacts/probes/ and fixtures/api/ are left
untouched. They contain real API responses with real post timestamps, and
editing a recorded artifact to change a date would falsify evidence.

The spoken disclosure lines in DEMO.md are kept in relative form, because
those are the script for the verbal version.

Deck regenerated from source, so the PNGs, PDF, and PPTX carry no dates.
</commit_message>
<xml_diff>
--- a/X_Arcade_deck.pptx
+++ b/X_Arcade_deck.pptx
@@ -510,7 +510,7 @@
           <a:lstStyle/>
           <a:p>
             <a:r>
-              <a:t>Open on the number. In April 2026 Nikita Bier said X was suspending roughly 208 bot accounts every minute (x.com/nikitabier/status/2042121229998682517). That figure and the other market claims in this deck come from the 7 August research sweep of public reporting. They are quoted as reported, not measured by us. Second beat: in November 2025 the About this account feature went viral as spot-the-fake entertainment. People already play this game for free in the quote tweets. X Arcade gives it a scoreboard. The line to land: we turned X's biggest embarrassment into a game.</a:t>
+              <a:t>Open on the number. In April 2026 Nikita Bier said X was suspending roughly 208 bot accounts every minute (x.com/nikitabier/status/2042121229998682517). That figure and the other market claims in this deck come from the research sweep of public reporting. They are quoted as reported, not measured by us. Second beat: in November 2025 the About this account feature went viral as spot-the-fake entertainment. People already play this game for free in the quote tweets. X Arcade gives it a scoreboard. The line to land: we turned X's biggest embarrassment into a game.</a:t>
             </a:r>
           </a:p>
         </p:txBody>
@@ -650,7 +650,7 @@
           <a:lstStyle/>
           <a:p>
             <a:r>
-              <a:t>This slide matches the lobby the judges will see: near-black, neon cyan, CRT scanlines, all CSS. The loop is one breath long. Real threads, pulled live on 7 August: deedydas on AI, Cointelegraph on crypto, Variety on movies, DeadlineDayLive on sports. Four replies are read verbatim from the thread, with post URLs preserved in the round files under cartridges/decoy/rounds/. Grok writes the fifth in the same register. Thirty seconds on the clock, two players, first correct tap wins. At reveal the real handles come back and Grok explains how it faked the register. The host voice is Grok TTS, five lines pre-rendered on 7 August.</a:t>
+              <a:t>This slide matches the lobby the judges will see: near-black, neon cyan, CRT scanlines, all CSS. The loop is one breath long. Real threads, pulled live: deedydas on AI, Cointelegraph on crypto, Variety on movies, DeadlineDayLive on sports. Four replies are read verbatim from the thread, with post URLs preserved in the round files under cartridges/decoy/rounds/. Grok writes the fifth in the same register. Thirty seconds on the clock, two players, first correct tap wins. At reveal the real handles come back and Grok explains how it faked the register. The host voice is Grok TTS, five lines pre-rendered at build time.</a:t>
             </a:r>
           </a:p>
         </p:txBody>
@@ -790,7 +790,7 @@
           <a:lstStyle/>
           <a:p>
             <a:r>
-              <a:t>The pipeline in five beats. x_search finds a trending thread, a second grounded call reads its replies, and the builder rejects any response that made no x_search call. Grok writes the imposter. Five deterministic gates screen every round, fail closed, no override. The queue serves only clean rounds. The four numbers below are probes measured the morning of 7 August, saved under artifacts/probes/. The 42 second x_search latency is exactly why rounds pre-build into a queue and are never fetched inline. The proof beat: integration_check.py plays a full two-player round offline with a socket guard active, zero network egress, trace at artifacts/integration_trace.txt. Voice runs browser-direct over an ephemeral token endpoint, minted in 0.13 seconds, and no secret ever reaches the client.</a:t>
+              <a:t>The pipeline in five beats. x_search finds a trending thread, a second grounded call reads its replies, and the builder rejects any response that made no x_search call. Grok writes the imposter. Five deterministic gates screen every round, fail closed, no override. The queue serves only clean rounds. The four numbers below are probes measured at build time, saved under artifacts/probes/. The 42 second x_search latency is exactly why rounds pre-build into a queue and are never fetched inline. The proof beat: integration_check.py plays a full two-player round offline with a socket guard active, zero network egress, trace at artifacts/integration_trace.txt. Voice runs browser-direct over an ephemeral token endpoint, minted in 0.13 seconds, and no secret ever reaches the client.</a:t>
             </a:r>
           </a:p>
         </p:txBody>
@@ -930,7 +930,7 @@
           <a:lstStyle/>
           <a:p>
             <a:r>
-              <a:t>The platform claim rests on the seam. A cartridge ships rounds that satisfy one small contract in CONTRACT.md, and the cabinet supplies rooms, websocket state, scoring, the voice host, and the share card forge. The gates are what judges should remember: they run at load, deterministic, fail closed, and on 7 August they proved themselves on real content, rejecting the AI-topic round on G_SOURCE and G_URL failures, so five of six rounds serve. A rejected round is not a bug. It is the screen working. Crux, the second cartridge, exists as a sketch only and is claimed as exactly that.</a:t>
+              <a:t>The platform claim rests on the seam. A cartridge ships rounds that satisfy one small contract in CONTRACT.md, and the cabinet supplies rooms, websocket state, scoring, the voice host, and the share card forge. The gates are what judges should remember: they run at load, deterministic, fail closed, and they proved themselves on real content, rejecting the AI-topic round on G_SOURCE and G_URL failures, so five of six rounds serve. A rejected round is not a bug. It is the screen working. Crux, the second cartridge, exists as a sketch only and is claimed as exactly that.</a:t>
             </a:r>
           </a:p>
         </p:txBody>
@@ -1070,7 +1070,7 @@
           <a:lstStyle/>
           <a:p>
             <a:r>
-              <a:t>Close on candor. The whole thing was built yesterday, the day before the event, on the xAI API surfaces: x_search, Grok 4.5 text, Imagine image, Grok voice TTS. What is real: live rounds from real threads, two-player websocket rooms, gates that rejected real content on 7 August, and an offline proof with zero network egress. What is staged and stated as staged: the post-back to X and the pre-generated video. The ask is small and concrete: ship one cartridge behind a real X surface and instrument the guess stream to test the flywheel thesis for real.</a:t>
+              <a:t>Close on candor. The whole thing was built before the event, on the xAI API surfaces: x_search, Grok 4.5 text, Imagine image, Grok voice TTS. What is real: live rounds from real threads, two-player websocket rooms, gates that rejected real content, and an offline proof with zero network egress. What is staged and stated as staged: the post-back to X and the pre-generated video. The ask is small and concrete: ship one cartridge behind a real X surface and instrument the guess stream to test the flywheel thesis for real.</a:t>
             </a:r>
           </a:p>
         </p:txBody>

</xml_diff>

<commit_message>
Refresh the pitch deck: open with X's own words, current facts
Slides 1 and 2 open on Nikita Bier's public posts, per Mohit's direction,
rendered as native tweet cards from committed quote data so there is no
x.com screenshot or login-wall dependency. Quotes are verbatim with handle,
date, and URL cited on each card. Reported engagement stays in presenter
notes, marked reported.

The rest is brought current: six-round matches with a results screen, TEXT
and GIF round modes, per-player pick attribution, the opaque-media anti-cheat
story, the fast-model commentator probe, twelve committed topic rounds, and
the public /stats usage page as the closing proof surface. Every number
traces to a committed probe or run. My own prose carries no em dashes; the
Bier quotes keep their original punctuation as quoted third-party content.

Deck outputs (html, pdf, pptx, portable, slide PNGs) rebuilt from source.
No app code touched; no deploy.
</commit_message>
<xml_diff>
--- a/X_Arcade_deck.pptx
+++ b/X_Arcade_deck.pptx
@@ -510,7 +510,7 @@
           <a:lstStyle/>
           <a:p>
             <a:r>
-              <a:t>Open on the number. In April 2026 Nikita Bier said X was suspending roughly 208 bot accounts every minute (x.com/nikitabier/status/2042121229998682517). That figure and the other market claims in this deck come from the research sweep of public reporting. They are quoted as reported, not measured by us. Second beat: in November 2025 the About this account feature went viral as spot-the-fake entertainment. People already play this game for free in the quote tweets. X Arcade gives it a scoreboard. The line to land: we turned X's biggest embarrassment into a game.</a:t>
+              <a:t>Open on the platform's own words, per Mohit's direction. This is X's head of product stating the mission in February 2026: the platform exists to give people an authentic pulse on humanity, and nothing is more unsettling than machine text wearing a human face. Decoy is that sentence turned into a game. The quote is verbatim from the public post at the URL on the slide. Land the beat: we did not invent this problem statement. X wrote it. We built the product for it.</a:t>
             </a:r>
           </a:p>
         </p:txBody>
@@ -580,7 +580,7 @@
           <a:lstStyle/>
           <a:p>
             <a:r>
-              <a:t>Three reported facts make the lane. First, X has never shipped a game on the platform in twenty years. Second, Musk publicly promised an AI-generated game from an xAI studio by the end of 2026, and nothing has shipped. Third, the head of product resigned two days ago, on 5 August, so the roadmap that would own this is unowned this week. WeChat is the model to name: its mini-game layer is a load-bearing part of the super-app moat. Hold the AI21 precedent for questions: Human or Not drew a reported ten million conversations in a month in 2023, then shut down. Appetite proven, surface abandoned. All of these are external claims from the research sweep, not our measurements.</a:t>
+              <a:t>Three receipts, all public posts from X's head of product, quoted verbatim with dates and URLs on the slide. July 24: 42,000 chatbot accounts removed, with the bright line named, no AI engagement without a human in the loop. July 31: the slop-ocalypse framing. January 15: the InfoFi ban, X kills apps whose incentives manufacture slop. Reported engagement on the purge post was about 62.9k likes, quoted as reported, not measured by us. The gap: for all that war footing, X has never shipped a game, and the promised AI game from October 2025 remains unshipped. The lane is open and the mission is stated. Next slide is what we drove into it.</a:t>
             </a:r>
           </a:p>
         </p:txBody>
@@ -650,7 +650,7 @@
           <a:lstStyle/>
           <a:p>
             <a:r>
-              <a:t>This slide matches the lobby the judges will see: near-black, neon cyan, CRT scanlines, all CSS. The loop is one breath long. Real threads, pulled live: deedydas on AI, Cointelegraph on crypto, Variety on movies, DeadlineDayLive on sports. Four replies are read verbatim from the thread, with post URLs preserved in the round files under cartridges/decoy/rounds/. Grok writes the fifth in the same register. Thirty seconds on the clock, two players, first correct tap wins. At reveal the real handles come back and Grok explains how it faked the register. The host voice is Grok TTS, five lines pre-rendered at build time.</a:t>
+              <a:t>The loop is one breath long. A real post, four replies read verbatim from the thread, one imposter Grok wrote to match the thread's register. Thirty seconds to tap the machine. New today: matches cap at six rounds and end on a results screen with standings, rounds alternate between text and GIF modes where the fake is an Imagine-generated clip hidden among real reaction GIFs, and the reveal chips every card with who picked it. Twelve topic rounds are committed across sports, gaming, science, space, music, movies, food, crypto, ai, tech, travel, and nba. The live demo build plays six of them with GIF rounds enabled.</a:t>
             </a:r>
           </a:p>
         </p:txBody>
@@ -720,7 +720,7 @@
           <a:lstStyle/>
           <a:p>
             <a:r>
-              <a:t>Stop talking and play. Open two tabs, both join room GROK, and the round starts the moment the second player joins. Hand a judge player two. If the venue network dies, the demo runs entirely offline from committed fixtures, and ?mock=1 puts the stage into a scripted state as the worst-case fallback.</a:t>
+              <a:t>Stop talking and play. The QR on screen drops everyone into room GROK. There is no host to wait for: the first player in a lobby arms a ten second countdown and the room runs itself from there, reveal to next round on a clock, with any player able to skip the wait. A lone judge clicking the link at 2am gets a real game against the house. If the venue network dies, the demo runs offline from committed fixtures with zero network egress, proven by a socket guard. Open the Space ten minutes before the slot so the container is warm.</a:t>
             </a:r>
           </a:p>
         </p:txBody>
@@ -790,7 +790,7 @@
           <a:lstStyle/>
           <a:p>
             <a:r>
-              <a:t>The pipeline in five beats. x_search finds a trending thread, a second grounded call reads its replies, and the builder rejects any response that made no x_search call. Grok writes the imposter. Five deterministic gates screen every round, fail closed, no override. The queue serves only clean rounds. The four numbers below are probes measured at build time, saved under artifacts/probes/. The 42 second x_search latency is exactly why rounds pre-build into a queue and are never fetched inline. The proof beat: integration_check.py plays a full two-player round offline with a socket guard active, zero network egress, trace at artifacts/integration_trace.txt. Voice runs browser-direct over an ephemeral token endpoint, minted in 0.13 seconds, and no secret ever reaches the client.</a:t>
+              <a:t>Five beats: x_search finds a live thread, a second grounded call reads its replies verbatim and rejects any response that made no search call, Grok writes the imposter, five deterministic gates screen the round and fail closed, and the queue serves only clean rounds. All probe numbers are measured and committed under artifacts/probes/. The commentator agent runs on a fast model because we measured the big one at 5.3 to 5.9 seconds per line versus 0.6 (artifacts/probes/host_agent_chat.json). Anti-cheat runs deeper than field stripping: during guessing, real media URLs never leave the server. Every reply's clip serves through an opaque per-round URL with identical shape and headers, because the decoy used to be identifiable three ways without playing, by its URL path, by being the only mp4, and by a pending status only a decoy could have. Proven closed by fetching every media URL across twelve straight rounds.</a:t>
             </a:r>
           </a:p>
         </p:txBody>
@@ -860,7 +860,7 @@
           <a:lstStyle/>
           <a:p>
             <a:r>
-              <a:t>Label this slide honestly and it gets stronger, not weaker. Every guess is a human judgment about what reads as machine-written, attached to real content, at game speed. Correct guesses say this text reads human. Wrong guesses are the interesting half: a real person whose reply reads like a bot. Aggregated, that is the labeled signal a bot-detection stack is starved for, the 208-a-minute problem from the first slide. We have measured none of it. The claim is that the loop exists and the game produces the labels as a side effect of being fun.</a:t>
+              <a:t>Tie this straight back to slide two: X drew the bright line at AI engagement with no human in the loop, and enforcement of that line is starved for labeled data about what reads as machine-written to actual humans. Every Decoy guess is exactly that label, attached to real content, at game speed. The wrong guesses are the richest half, real people whose replies read like bots. We have measured none of it and say so on the slide. The claim is that the loop exists and the game mints the labels as a side effect of being fun.</a:t>
             </a:r>
           </a:p>
         </p:txBody>
@@ -930,7 +930,7 @@
           <a:lstStyle/>
           <a:p>
             <a:r>
-              <a:t>The platform claim rests on the seam. A cartridge ships rounds that satisfy one small contract in CONTRACT.md, and the cabinet supplies rooms, websocket state, scoring, the voice host, and the share card forge. The gates are what judges should remember: they run at load, deterministic, fail closed, and they proved themselves on real content, rejecting the AI-topic round on G_SOURCE and G_URL failures, so five of six rounds serve. A rejected round is not a bug. It is the screen working. Crux, the second cartridge, exists as a sketch only and is claimed as exactly that.</a:t>
+              <a:t>The platform claim rests on the seam. A cartridge ships rounds that satisfy one small contract, and the cabinet supplies rooms, the session clock, scoring, the voice host, the commentator agent, and the share card forge. The gates run at load, deterministic, and fail closed, and they proved themselves on real content: an event-day live pull was rejected on G_URL and never served. The gates check integrity, not taste, so freshly pulled rounds also get a human read before they serve. That is the answer an ads buyer needs first, a deterministic screen that a brand never sits behind.</a:t>
             </a:r>
           </a:p>
         </p:txBody>
@@ -1000,7 +1000,7 @@
           <a:lstStyle/>
           <a:p>
             <a:r>
-              <a:t>Two ad surfaces fall out of the game. Sponsored arenas: a brand picks a topic, gets an accent color and its name on the arena, and the game stays identical. The share card: the winner's card carries the sponsor mark, so every share is brand reach next to the topic the brand chose. The ad module ships with its cpm_note field set to the literal string ILLUSTRATIVE so no invented market figure appears anywhere, and every sponsor name in the demo config is fictional. To be plain: any revenue number attached to this idea is a projection. The safety gates run before any arena is served, which is the brand-safety answer an ads buyer needs first.</a:t>
+              <a:t>Two ad surfaces fall out of the game. Sponsored arenas: a brand picks a topic, gets an accent and its name on the arena, the game stays identical. The share card: the winner's card carries the sponsor mark, so every organic share is brand reach next to a topic the brand chose. Tie it to the receipts: X's InfoFi ban killed apps that pay users to post, because that incentive manufactures slop, while a sponsored arena aligns the incentive with brand-safe, human play. The ad module ships with its cpm field set to the literal string ILLUSTRATIVE and every demo sponsor is fictional, so no invented market number appears anywhere. Any revenue figure attached to this is a projection, said plainly.</a:t>
             </a:r>
           </a:p>
         </p:txBody>
@@ -1070,7 +1070,7 @@
           <a:lstStyle/>
           <a:p>
             <a:r>
-              <a:t>Close on candor. The whole thing was built before the event, on the xAI API surfaces: x_search, Grok 4.5 text, Imagine image, Grok voice TTS. What is real: live rounds from real threads, two-player websocket rooms, gates that rejected real content, and an offline proof with zero network egress. What is staged and stated as staged: the post-back to X and the pre-generated video. The ask is small and concrete: ship one cartridge behind a real X surface and instrument the guess stream to test the flywheel thesis for real.</a:t>
+              <a:t>Close on candor. Built on the xAI API surfaces: x_search, Grok 4.5 text, Imagine image and video, Grok voice. What is real: live rounds from real threads, six-round matches, GIF rounds with an opaque anti-cheat, gates that rejected real content on event day, and an offline proof with zero network egress. What is staged and stated as staged: the post-back to X. The usage page at /stats counts real player actions and says its counters reset on deploy, so the number is honest, not an impression count. The ask is small and concrete: ship one cartridge behind a real X surface and instrument the guess stream to test the flywheel thesis for real.</a:t>
             </a:r>
           </a:p>
         </p:txBody>

</xml_diff>

<commit_message>
Embed the spoken demo script into slide presenter notes
Each slide's notes now carry the verbatim SAY lines plus a stage CUE, so
pressing N in the HTML or opening presenter view in PowerPoint shows exactly
what to say. The flow is: QR goes up at slide 4 and the audience joins during
the rest of the deck, then the live round runs from the app right after slide
9, when the room is already full.
</commit_message>
<xml_diff>
--- a/X_Arcade_deck.pptx
+++ b/X_Arcade_deck.pptx
@@ -510,7 +510,7 @@
           <a:lstStyle/>
           <a:p>
             <a:r>
-              <a:t>Open on the platform's own words, per Mohit's direction. This is X's head of product stating the mission in February 2026: the platform exists to give people an authentic pulse on humanity, and nothing is more unsettling than machine text wearing a human face. Decoy is that sentence turned into a game. The quote is verbatim from the public post at the URL on the slide. Land the beat: we did not invent this problem statement. X wrote it. We built the product for it.</a:t>
+              <a:t>SAY: This is X's head of product, writing in February. The platform exists to give people a pulse on humanity, and nothing is more unsettling than reading what you think is a person and finding it was a machine. We did not invent that problem. X wrote it down. We built the product for it.  CUE: the quote is on screen, point and paraphrase, do not read it line by line.</a:t>
             </a:r>
           </a:p>
         </p:txBody>
@@ -580,7 +580,7 @@
           <a:lstStyle/>
           <a:p>
             <a:r>
-              <a:t>Three receipts, all public posts from X's head of product, quoted verbatim with dates and URLs on the slide. July 24: 42,000 chatbot accounts removed, with the bright line named, no AI engagement without a human in the loop. July 31: the slop-ocalypse framing. January 15: the InfoFi ban, X kills apps whose incentives manufacture slop. Reported engagement on the purge post was about 62.9k likes, quoted as reported, not measured by us. The gap: for all that war footing, X has never shipped a game, and the promised AI game from October 2025 remains unshipped. The lane is open and the mission is stated. Next slide is what we drove into it.</a:t>
+              <a:t>SAY: And X is already at war with this. Forty-two thousand chatbot accounts removed in one sweep. The InfoFi ban, killing the apps that pay people to post slop. They named the enemy, the slop-ocalypse. But in twenty years X has never shipped a game, and the AI game they promised is still unshipped. That lane is open and the mission is already stated.  CUE: point at the three cards, do not read them. The 62.9k likes figure is reported, not ours, keep it off the mic.</a:t>
             </a:r>
           </a:p>
         </p:txBody>
@@ -650,7 +650,7 @@
           <a:lstStyle/>
           <a:p>
             <a:r>
-              <a:t>The loop is one breath long. A real post, four replies read verbatim from the thread, one imposter Grok wrote to match the thread's register. Thirty seconds to tap the machine. New today: matches cap at six rounds and end on a results screen with standings, rounds alternate between text and GIF modes where the fake is an Imagine-generated clip hidden among real reaction GIFs, and the reveal chips every card with who picked it. Twelve topic rounds are committed across sports, gaming, science, space, music, movies, food, crypto, ai, tech, travel, and nba. The live demo build plays six of them with GIF rounds enabled.</a:t>
+              <a:t>SAY: Here is what we built. One real trending thread off X. Four of these replies are real people, one was written by Grok to blend in. Thirty seconds to find the machine. Matches run six rounds and end on a results screen. Some rounds are text, some are GIF rounds where the fake is an Imagine video.  CUE: this is the shape of the game. We play it live at the end, not now.</a:t>
             </a:r>
           </a:p>
         </p:txBody>
@@ -720,7 +720,7 @@
           <a:lstStyle/>
           <a:p>
             <a:r>
-              <a:t>Stop talking and play. The QR on screen drops everyone into room GROK. There is no host to wait for: the first player in a lobby arms a ten second countdown and the room runs itself from there, reveal to next round on a clock, with any player able to skip the wait. A lone judge clicking the link at 2am gets a real game against the house. If the venue network dies, the demo runs offline from committed fixtures with zero network egress, proven by a socket guard. Open the Space ten minutes before the slot so the container is warm.</a:t>
+              <a:t>SAY: Before we go further, take out your phone and scan this code. It drops you straight into the room. There is no host to wait for, the room runs itself on a clock. Get in now, and we will play a live round together at the end.  CUE: THE QR MUST BE ON SCREEN HERE. The audience joins during the rest of the deck, so the room is full by slide 9. Do not tap START yet.</a:t>
             </a:r>
           </a:p>
         </p:txBody>
@@ -790,7 +790,7 @@
           <a:lstStyle/>
           <a:p>
             <a:r>
-              <a:t>Five beats: x_search finds a live thread, a second grounded call reads its replies verbatim and rejects any response that made no search call, Grok writes the imposter, five deterministic gates screen the round and fail closed, and the queue serves only clean rounds. All probe numbers are measured and committed under artifacts/probes/. The commentator agent runs on a fast model because we measured the big one at 5.3 to 5.9 seconds per line versus 0.6 (artifacts/probes/host_agent_chat.json). Anti-cheat runs deeper than field stripping: during guessing, real media URLs never leave the server. Every reply's clip serves through an opaque per-round URL with identical shape and headers, because the decoy used to be identifiable three ways without playing, by its URL path, by being the only mp4, and by a pending status only a decoy could have. Proven closed by fetching every media URL across twelve straight rounds.</a:t>
+              <a:t>SAY: Under the hood it is five beats. A search finds a live thread, a second grounded call reads the real replies, Grok writes the imposter, five deterministic gates screen the round and fail closed, and only clean rounds serve. One event-day pull was rejected for an embedded link and never served. And you cannot cheat: during guessing, the answer never leaves the server.  CUE: only go deep here if the room is technical, otherwise one sentence and move on.</a:t>
             </a:r>
           </a:p>
         </p:txBody>
@@ -860,7 +860,7 @@
           <a:lstStyle/>
           <a:p>
             <a:r>
-              <a:t>Tie this straight back to slide two: X drew the bright line at AI engagement with no human in the loop, and enforcement of that line is starved for labeled data about what reads as machine-written to actual humans. Every Decoy guess is exactly that label, attached to real content, at game speed. The wrong guesses are the richest half, real people whose replies read like bots. We have measured none of it and say so on the slide. The claim is that the loop exists and the game mints the labels as a side effect of being fun.</a:t>
+              <a:t>SAY: Here is the thesis. X drew a bright line at AI with no human in the loop. Enforcing that line is starved for data about what reads as machine-written to real people. Every guess in the game is exactly that label, and the wrong guesses are the richest half, real people who read like bots. We have measured none of this yet, and it says so on the slide.  CUE: say the word thesis out loud, it is your honesty anchor.</a:t>
             </a:r>
           </a:p>
         </p:txBody>
@@ -930,7 +930,7 @@
           <a:lstStyle/>
           <a:p>
             <a:r>
-              <a:t>The platform claim rests on the seam. A cartridge ships rounds that satisfy one small contract, and the cabinet supplies rooms, the session clock, scoring, the voice host, the commentator agent, and the share card forge. The gates run at load, deterministic, and fail closed, and they proved themselves on real content: an event-day live pull was rejected on G_URL and never served. The gates check integrity, not taste, so freshly pulled rounds also get a human read before they serve. That is the answer an ads buyer needs first, a deterministic screen that a brand never sits behind.</a:t>
+              <a:t>SAY: This is a platform, not one game. A cartridge ships rounds behind one small contract, and the cabinet supplies the rooms, the clock, scoring, the voice host, and the share cards. The gates are infrastructure. A rejected round is not a bug, it is the screen working.  CUE: keep this short unless a judge asks.</a:t>
             </a:r>
           </a:p>
         </p:txBody>
@@ -1000,7 +1000,7 @@
           <a:lstStyle/>
           <a:p>
             <a:r>
-              <a:t>Two ad surfaces fall out of the game. Sponsored arenas: a brand picks a topic, gets an accent and its name on the arena, the game stays identical. The share card: the winner's card carries the sponsor mark, so every organic share is brand reach next to a topic the brand chose. Tie it to the receipts: X's InfoFi ban killed apps that pay users to post, because that incentive manufactures slop, while a sponsored arena aligns the incentive with brand-safe, human play. The ad module ships with its cpm field set to the literal string ILLUSTRATIVE and every demo sponsor is fictional, so no invented market number appears anywhere. Any revenue figure attached to this is a projection, said plainly.</a:t>
+              <a:t>SAY: The money is the sponsored arena. A brand picks a topic, the game stays identical, and the winner's share card carries the sponsor mark, so every share is brand reach next to a topic the brand chose. Tie it to the receipts: X killed pay-to-post because it makes slop, and this aligns the incentive with brand-safe human play. Every number here is illustrative and labeled as such.  CUE: never quote a market size, there is not a real one.</a:t>
             </a:r>
           </a:p>
         </p:txBody>
@@ -1070,7 +1070,7 @@
           <a:lstStyle/>
           <a:p>
             <a:r>
-              <a:t>Close on candor. Built on the xAI API surfaces: x_search, Grok 4.5 text, Imagine image and video, Grok voice. What is real: live rounds from real threads, six-round matches, GIF rounds with an opaque anti-cheat, gates that rejected real content on event day, and an offline proof with zero network egress. What is staged and stated as staged: the post-back to X. The usage page at /stats counts real player actions and says its counters reset on deploy, so the number is honest, not an impression count. The ask is small and concrete: ship one cartridge behind a real X surface and instrument the guess stream to test the flywheel thesis for real.</a:t>
+              <a:t>SAY: Built in a day, on the xAI API, live and playable right now. Usage is public and honest at slash stats, real player actions, never impressions. What is staged, the post-back to X, we say so. The ask is small: ship one cartridge behind a real X surface and instrument the guess stream. And now, let us actually play.  CUE: SWITCH TO THE APP. The room is already full from slide 4. Tap START, run one round, land the reveal. Done.</a:t>
             </a:r>
           </a:p>
         </p:txBody>

</xml_diff>

<commit_message>
Add system-design diagram, technical-complexity, and war-scars slides
Deck grows to 12 slides for the judging criteria. New slide 6 embeds an
Excalidraw system-design diagram (drawn via the Excalidraw MCP, exported to
slides/system_design.png): grouped boundaries for players, the HF Space, the
offline round pipeline, and the xAI API, with five numbered flows and the
measured probe latencies. Slide 7 is the explicit technical-complexity slide
(grounded two-call pull, opaque uniform media, time-driven sessions, offline
zero-egress proof, 32-check abuse battery). Slide 8 is war scars, each a real
build-day scar mapped to what it changed. All three carry SAY/CUE presenter
notes.

Pipeline hardened so this does not bite again: make_portable.py inlines every
figure image (not just the share card), and render_all.sh derives the slide
count from the deck data instead of a hardcoded 1-9. No app code; no deploy.
</commit_message>
<xml_diff>
--- a/X_Arcade_deck.pptx
+++ b/X_Arcade_deck.pptx
@@ -14,6 +14,9 @@
     <p:sldId id="262" r:id="rId14"/>
     <p:sldId id="263" r:id="rId15"/>
     <p:sldId id="264" r:id="rId16"/>
+    <p:sldId id="265" r:id="rId17"/>
+    <p:sldId id="266" r:id="rId18"/>
+    <p:sldId id="267" r:id="rId19"/>
   </p:sldIdLst>
   <p:sldSz cx="12191695" cy="6858000" type="screen4x3"/>
   <p:notesSz cx="6858000" cy="9144000"/>
@@ -535,6 +538,216 @@
 </p:notes>
 </file>
 
+<file path=ppt/notesSlides/notesSlide10.xml><?xml version="1.0" encoding="utf-8"?>
+<p:notes xmlns:a="http://schemas.openxmlformats.org/drawingml/2006/main" xmlns:p="http://schemas.openxmlformats.org/presentationml/2006/main" xmlns:r="http://schemas.openxmlformats.org/officeDocument/2006/relationships">
+  <p:cSld>
+    <p:spTree>
+      <p:nvGrpSpPr>
+        <p:cNvPr id="1" name=""/>
+        <p:cNvGrpSpPr/>
+        <p:nvPr/>
+      </p:nvGrpSpPr>
+      <p:grpSpPr>
+        <a:xfrm>
+          <a:off x="0" y="0"/>
+          <a:ext cx="0" cy="0"/>
+          <a:chOff x="0" y="0"/>
+          <a:chExt cx="0" cy="0"/>
+        </a:xfrm>
+      </p:grpSpPr>
+      <p:sp>
+        <p:nvSpPr>
+          <p:cNvPr id="2" name="Slide Image Placeholder 1"/>
+          <p:cNvSpPr>
+            <a:spLocks noGrp="1"/>
+          </p:cNvSpPr>
+          <p:nvPr>
+            <p:ph type="sldImg" idx="2"/>
+          </p:nvPr>
+        </p:nvSpPr>
+        <p:spPr/>
+      </p:sp>
+      <p:sp>
+        <p:nvSpPr>
+          <p:cNvPr id="3" name="Notes Placeholder 2"/>
+          <p:cNvSpPr>
+            <a:spLocks noGrp="1"/>
+          </p:cNvSpPr>
+          <p:nvPr>
+            <p:ph type="body" idx="3" sz="quarter"/>
+          </p:nvPr>
+        </p:nvSpPr>
+        <p:spPr/>
+        <p:txBody>
+          <a:bodyPr/>
+          <a:lstStyle/>
+          <a:p>
+            <a:r>
+              <a:t>SAY: This is a platform, not one game. A cartridge ships rounds behind one small contract, and the cabinet supplies the rooms, the clock, scoring, the voice host, and the share cards. The gates are infrastructure. A rejected round is not a bug, it is the screen working.  CUE: keep this short unless a judge asks.</a:t>
+            </a:r>
+          </a:p>
+        </p:txBody>
+      </p:sp>
+      <p:sp>
+        <p:nvSpPr>
+          <p:cNvPr id="4" name="Slide Number Placeholder 3"/>
+          <p:cNvSpPr>
+            <a:spLocks noGrp="1"/>
+          </p:cNvSpPr>
+          <p:nvPr>
+            <p:ph type="sldNum" idx="5" sz="quarter"/>
+          </p:nvPr>
+        </p:nvSpPr>
+        <p:spPr/>
+      </p:sp>
+    </p:spTree>
+  </p:cSld>
+  <p:clrMapOvr>
+    <a:masterClrMapping/>
+  </p:clrMapOvr>
+</p:notes>
+</file>
+
+<file path=ppt/notesSlides/notesSlide11.xml><?xml version="1.0" encoding="utf-8"?>
+<p:notes xmlns:a="http://schemas.openxmlformats.org/drawingml/2006/main" xmlns:p="http://schemas.openxmlformats.org/presentationml/2006/main" xmlns:r="http://schemas.openxmlformats.org/officeDocument/2006/relationships">
+  <p:cSld>
+    <p:spTree>
+      <p:nvGrpSpPr>
+        <p:cNvPr id="1" name=""/>
+        <p:cNvGrpSpPr/>
+        <p:nvPr/>
+      </p:nvGrpSpPr>
+      <p:grpSpPr>
+        <a:xfrm>
+          <a:off x="0" y="0"/>
+          <a:ext cx="0" cy="0"/>
+          <a:chOff x="0" y="0"/>
+          <a:chExt cx="0" cy="0"/>
+        </a:xfrm>
+      </p:grpSpPr>
+      <p:sp>
+        <p:nvSpPr>
+          <p:cNvPr id="2" name="Slide Image Placeholder 1"/>
+          <p:cNvSpPr>
+            <a:spLocks noGrp="1"/>
+          </p:cNvSpPr>
+          <p:nvPr>
+            <p:ph type="sldImg" idx="2"/>
+          </p:nvPr>
+        </p:nvSpPr>
+        <p:spPr/>
+      </p:sp>
+      <p:sp>
+        <p:nvSpPr>
+          <p:cNvPr id="3" name="Notes Placeholder 2"/>
+          <p:cNvSpPr>
+            <a:spLocks noGrp="1"/>
+          </p:cNvSpPr>
+          <p:nvPr>
+            <p:ph type="body" idx="3" sz="quarter"/>
+          </p:nvPr>
+        </p:nvSpPr>
+        <p:spPr/>
+        <p:txBody>
+          <a:bodyPr/>
+          <a:lstStyle/>
+          <a:p>
+            <a:r>
+              <a:t>SAY: The money is the sponsored arena. A brand picks a topic, the game stays identical, and the winner's share card carries the sponsor mark, so every share is brand reach next to a topic the brand chose. Tie it to the receipts: X killed pay-to-post because it makes slop, and this aligns the incentive with brand-safe human play. Every number here is illustrative and labeled as such.  CUE: never quote a market size, there is not a real one.</a:t>
+            </a:r>
+          </a:p>
+        </p:txBody>
+      </p:sp>
+      <p:sp>
+        <p:nvSpPr>
+          <p:cNvPr id="4" name="Slide Number Placeholder 3"/>
+          <p:cNvSpPr>
+            <a:spLocks noGrp="1"/>
+          </p:cNvSpPr>
+          <p:nvPr>
+            <p:ph type="sldNum" idx="5" sz="quarter"/>
+          </p:nvPr>
+        </p:nvSpPr>
+        <p:spPr/>
+      </p:sp>
+    </p:spTree>
+  </p:cSld>
+  <p:clrMapOvr>
+    <a:masterClrMapping/>
+  </p:clrMapOvr>
+</p:notes>
+</file>
+
+<file path=ppt/notesSlides/notesSlide12.xml><?xml version="1.0" encoding="utf-8"?>
+<p:notes xmlns:a="http://schemas.openxmlformats.org/drawingml/2006/main" xmlns:p="http://schemas.openxmlformats.org/presentationml/2006/main" xmlns:r="http://schemas.openxmlformats.org/officeDocument/2006/relationships">
+  <p:cSld>
+    <p:spTree>
+      <p:nvGrpSpPr>
+        <p:cNvPr id="1" name=""/>
+        <p:cNvGrpSpPr/>
+        <p:nvPr/>
+      </p:nvGrpSpPr>
+      <p:grpSpPr>
+        <a:xfrm>
+          <a:off x="0" y="0"/>
+          <a:ext cx="0" cy="0"/>
+          <a:chOff x="0" y="0"/>
+          <a:chExt cx="0" cy="0"/>
+        </a:xfrm>
+      </p:grpSpPr>
+      <p:sp>
+        <p:nvSpPr>
+          <p:cNvPr id="2" name="Slide Image Placeholder 1"/>
+          <p:cNvSpPr>
+            <a:spLocks noGrp="1"/>
+          </p:cNvSpPr>
+          <p:nvPr>
+            <p:ph type="sldImg" idx="2"/>
+          </p:nvPr>
+        </p:nvSpPr>
+        <p:spPr/>
+      </p:sp>
+      <p:sp>
+        <p:nvSpPr>
+          <p:cNvPr id="3" name="Notes Placeholder 2"/>
+          <p:cNvSpPr>
+            <a:spLocks noGrp="1"/>
+          </p:cNvSpPr>
+          <p:nvPr>
+            <p:ph type="body" idx="3" sz="quarter"/>
+          </p:nvPr>
+        </p:nvSpPr>
+        <p:spPr/>
+        <p:txBody>
+          <a:bodyPr/>
+          <a:lstStyle/>
+          <a:p>
+            <a:r>
+              <a:t>SAY: Built in a day, on the xAI API, live and playable right now. Usage is public and honest at slash stats, real player actions, never impressions. What is staged, the post-back to X, we say so. The ask is small: ship one cartridge behind a real X surface and instrument the guess stream. And now, let us actually play.  CUE: SWITCH TO THE APP. The room is already full from slide 4. Tap START, run one round, land the reveal. Done.</a:t>
+            </a:r>
+          </a:p>
+        </p:txBody>
+      </p:sp>
+      <p:sp>
+        <p:nvSpPr>
+          <p:cNvPr id="4" name="Slide Number Placeholder 3"/>
+          <p:cNvSpPr>
+            <a:spLocks noGrp="1"/>
+          </p:cNvSpPr>
+          <p:nvPr>
+            <p:ph type="sldNum" idx="5" sz="quarter"/>
+          </p:nvPr>
+        </p:nvSpPr>
+        <p:spPr/>
+      </p:sp>
+    </p:spTree>
+  </p:cSld>
+  <p:clrMapOvr>
+    <a:masterClrMapping/>
+  </p:clrMapOvr>
+</p:notes>
+</file>
+
 <file path=ppt/notesSlides/notesSlide2.xml><?xml version="1.0" encoding="utf-8"?>
 <p:notes xmlns:a="http://schemas.openxmlformats.org/drawingml/2006/main" xmlns:p="http://schemas.openxmlformats.org/presentationml/2006/main" xmlns:r="http://schemas.openxmlformats.org/officeDocument/2006/relationships">
   <p:cSld>
@@ -860,7 +1073,7 @@
           <a:lstStyle/>
           <a:p>
             <a:r>
-              <a:t>SAY: Here is the thesis. X drew a bright line at AI with no human in the loop. Enforcing that line is starved for data about what reads as machine-written to real people. Every guess in the game is exactly that label, and the wrong guesses are the richest half, real people who read like bots. We have measured none of this yet, and it says so on the slide.  CUE: say the word thesis out loud, it is your honesty anchor.</a:t>
+              <a:t>SAY: Here is the whole system on one page. On the left, players join over a websocket. In the middle, one FastAPI server holds the rooms in memory, runs the clock, and serves rounds. The rounds are not pulled live during play, that is the offline pipeline at the bottom: a search finds the thread, Grok writes the imposter, it gets recorded to fixtures and committed. And the slow, expensive xAI calls on the right, Imagine and voice, are all off the round path, fired async so they never block a guess.  CUE: trace the five numbered arrows if the room is technical, otherwise say the one line: everything slow is pre-built or async, nothing slow is on the clock.</a:t>
             </a:r>
           </a:p>
         </p:txBody>
@@ -930,7 +1143,7 @@
           <a:lstStyle/>
           <a:p>
             <a:r>
-              <a:t>SAY: This is a platform, not one game. A cartridge ships rounds behind one small contract, and the cabinet supplies the rooms, the clock, scoring, the voice host, and the share cards. The gates are infrastructure. A rejected round is not a bug, it is the screen working.  CUE: keep this short unless a judge asks.</a:t>
+              <a:t>SAY: The game is easy to describe and hard to make correct. Three things I would point a judge at. One, we do not trust the model to read the thread, we make two grounded calls and reject any response that did not actually search. Two, the anti-cheat: during guessing the answer never leaves the server, and every reply's media is served through an identical opaque URL, because the fake used to be findable in dev tools three different ways. Three, the whole thing runs offline from fixtures with a socket guard that fails on any network call, and a 32-check abuse suite, including a thirty-player room, passes against the live deploy.  CUE: this is the technical-complexity slide, every number is from a committed run.</a:t>
             </a:r>
           </a:p>
         </p:txBody>
@@ -1000,7 +1213,7 @@
           <a:lstStyle/>
           <a:p>
             <a:r>
-              <a:t>SAY: The money is the sponsored arena. A brand picks a topic, the game stays identical, and the winner's share card carries the sponsor mark, so every share is brand reach next to a topic the brand chose. Tie it to the receipts: X killed pay-to-post because it makes slop, and this aligns the incentive with brand-safe human play. Every number here is illustrative and labeled as such.  CUE: never quote a market size, there is not a real one.</a:t>
+              <a:t>SAY: A few honest scars, all from today. We built host-controlled rooms and it produced three separate dead-button bugs where the client and server disagreed on who could start, so we deleted the host entirely and made the room run on a clock. The GIF decoy leaked three ways at once, its URL said decoy, it was the only mp4, and the client even labeled it, so now every reply's media serves through one identical opaque URL. And the gates check integrity, not taste, so live pulls kept landing on divisive threads that passed every gate, which is why a human still reads a fresh round before it serves.  CUE: tell one of these as a story if you have time, the dead-button one lands best.</a:t>
             </a:r>
           </a:p>
         </p:txBody>
@@ -1070,7 +1283,7 @@
           <a:lstStyle/>
           <a:p>
             <a:r>
-              <a:t>SAY: Built in a day, on the xAI API, live and playable right now. Usage is public and honest at slash stats, real player actions, never impressions. What is staged, the post-back to X, we say so. The ask is small: ship one cartridge behind a real X surface and instrument the guess stream. And now, let us actually play.  CUE: SWITCH TO THE APP. The room is already full from slide 4. Tap START, run one round, land the reveal. Done.</a:t>
+              <a:t>SAY: Here is the thesis. X drew a bright line at AI with no human in the loop. Enforcing that line is starved for data about what reads as machine-written to real people. Every guess in the game is exactly that label, and the wrong guesses are the richest half, real people who read like bots. We have measured none of this yet, and it says so on the slide.  CUE: say the word thesis out loud, it is your honesty anchor.</a:t>
             </a:r>
           </a:p>
         </p:txBody>
@@ -4079,6 +4292,132 @@
       <p:pic>
         <p:nvPicPr>
           <p:cNvPr id="2" name="Picture 1" descr="slide_01.png"/>
+          <p:cNvPicPr>
+            <a:picLocks noChangeAspect="1"/>
+          </p:cNvPicPr>
+          <p:nvPr/>
+        </p:nvPicPr>
+        <p:blipFill>
+          <a:blip r:embed="rId2"/>
+          <a:stretch>
+            <a:fillRect/>
+          </a:stretch>
+        </p:blipFill>
+        <p:spPr>
+          <a:xfrm>
+            <a:off x="0" y="0"/>
+            <a:ext cx="12191695" cy="6858000"/>
+          </a:xfrm>
+          <a:prstGeom prst="rect">
+            <a:avLst/>
+          </a:prstGeom>
+        </p:spPr>
+      </p:pic>
+    </p:spTree>
+  </p:cSld>
+  <p:clrMapOvr>
+    <a:masterClrMapping/>
+  </p:clrMapOvr>
+</p:sld>
+</file>
+
+<file path=ppt/slides/slide10.xml><?xml version="1.0" encoding="utf-8"?>
+<p:sld xmlns:a="http://schemas.openxmlformats.org/drawingml/2006/main" xmlns:p="http://schemas.openxmlformats.org/presentationml/2006/main" xmlns:r="http://schemas.openxmlformats.org/officeDocument/2006/relationships">
+  <p:cSld>
+    <p:spTree>
+      <p:nvGrpSpPr>
+        <p:cNvPr id="1" name=""/>
+        <p:cNvGrpSpPr/>
+        <p:nvPr/>
+      </p:nvGrpSpPr>
+      <p:grpSpPr/>
+      <p:pic>
+        <p:nvPicPr>
+          <p:cNvPr id="2" name="Picture 1" descr="slide_10.png"/>
+          <p:cNvPicPr>
+            <a:picLocks noChangeAspect="1"/>
+          </p:cNvPicPr>
+          <p:nvPr/>
+        </p:nvPicPr>
+        <p:blipFill>
+          <a:blip r:embed="rId2"/>
+          <a:stretch>
+            <a:fillRect/>
+          </a:stretch>
+        </p:blipFill>
+        <p:spPr>
+          <a:xfrm>
+            <a:off x="0" y="0"/>
+            <a:ext cx="12191695" cy="6858000"/>
+          </a:xfrm>
+          <a:prstGeom prst="rect">
+            <a:avLst/>
+          </a:prstGeom>
+        </p:spPr>
+      </p:pic>
+    </p:spTree>
+  </p:cSld>
+  <p:clrMapOvr>
+    <a:masterClrMapping/>
+  </p:clrMapOvr>
+</p:sld>
+</file>
+
+<file path=ppt/slides/slide11.xml><?xml version="1.0" encoding="utf-8"?>
+<p:sld xmlns:a="http://schemas.openxmlformats.org/drawingml/2006/main" xmlns:p="http://schemas.openxmlformats.org/presentationml/2006/main" xmlns:r="http://schemas.openxmlformats.org/officeDocument/2006/relationships">
+  <p:cSld>
+    <p:spTree>
+      <p:nvGrpSpPr>
+        <p:cNvPr id="1" name=""/>
+        <p:cNvGrpSpPr/>
+        <p:nvPr/>
+      </p:nvGrpSpPr>
+      <p:grpSpPr/>
+      <p:pic>
+        <p:nvPicPr>
+          <p:cNvPr id="2" name="Picture 1" descr="slide_11.png"/>
+          <p:cNvPicPr>
+            <a:picLocks noChangeAspect="1"/>
+          </p:cNvPicPr>
+          <p:nvPr/>
+        </p:nvPicPr>
+        <p:blipFill>
+          <a:blip r:embed="rId2"/>
+          <a:stretch>
+            <a:fillRect/>
+          </a:stretch>
+        </p:blipFill>
+        <p:spPr>
+          <a:xfrm>
+            <a:off x="0" y="0"/>
+            <a:ext cx="12191695" cy="6858000"/>
+          </a:xfrm>
+          <a:prstGeom prst="rect">
+            <a:avLst/>
+          </a:prstGeom>
+        </p:spPr>
+      </p:pic>
+    </p:spTree>
+  </p:cSld>
+  <p:clrMapOvr>
+    <a:masterClrMapping/>
+  </p:clrMapOvr>
+</p:sld>
+</file>
+
+<file path=ppt/slides/slide12.xml><?xml version="1.0" encoding="utf-8"?>
+<p:sld xmlns:a="http://schemas.openxmlformats.org/drawingml/2006/main" xmlns:p="http://schemas.openxmlformats.org/presentationml/2006/main" xmlns:r="http://schemas.openxmlformats.org/officeDocument/2006/relationships">
+  <p:cSld>
+    <p:spTree>
+      <p:nvGrpSpPr>
+        <p:cNvPr id="1" name=""/>
+        <p:cNvGrpSpPr/>
+        <p:nvPr/>
+      </p:nvGrpSpPr>
+      <p:grpSpPr/>
+      <p:pic>
+        <p:nvPicPr>
+          <p:cNvPr id="2" name="Picture 1" descr="slide_12.png"/>
           <p:cNvPicPr>
             <a:picLocks noChangeAspect="1"/>
           </p:cNvPicPr>

</xml_diff>